<commit_message>
decks: derive survey sample sizes from the JSONs instead of hardcoding them
Four literal sample sizes survived the n=134 re-analysis because they were
plain strings, not read from docs/survey_validation.json: the PES deck's
external-validation row said 'n = 86' and its Gantt said 'n = 87', and the
defense deck said 'n = 87' in two places. Now interpolated from
construct_validity.n (103), n_usable (104) and n_raw (134), so a future
re-analysis cannot leave a stale figure on a slide the panel reads.
Both decks rebuilt and scanned: no stale n, rho or p-value remains.
</commit_message>
<xml_diff>
--- a/docs/DEFENSE_DECK.pptx
+++ b/docs/DEFENSE_DECK.pptx
@@ -7469,7 +7469,7 @@
                 </a:solidFill>
                 <a:latin typeface="Calibri"/>
               </a:rPr>
-              <a:t>: the IGDS9-SF survey (n = 87) — no open dataset pairs the instrument with the pattern variables we measure</a:t>
+              <a:t>: the IGDS9-SF survey (n = 104 usable) — no open dataset pairs the instrument with the pattern variables we measure</a:t>
             </a:r>
           </a:p>
           <a:p>
@@ -10279,7 +10279,7 @@
                           </a:solidFill>
                           <a:latin typeface="Calibri"/>
                         </a:rPr>
-                        <a:t> vs IGDS9-SF (n = 87); accent-fairness audit; 7 research-integrity guards</a:t>
+                        <a:t> vs IGDS9-SF (n = 103); accent-fairness audit; 7 research-integrity guards</a:t>
                       </a:r>
                     </a:p>
                   </a:txBody>

</xml_diff>